<commit_message>
docs: add Bhanushree M and Bhuvana H R to team details
</commit_message>
<xml_diff>
--- a/docs/presentation/CardioTwin_Project_Presentation.pptx
+++ b/docs/presentation/CardioTwin_Project_Presentation.pptx
@@ -3356,7 +3356,7 @@
               </a:defRPr>
             </a:pPr>
             <a:r>
-              <a:t>• Team: Kanchana A &amp; Sinchana | BMS Institute of Technology and Management</a:t>
+              <a:t>• Team: Kanchana A, Sinchana, Bhanushree M, Bhuvana H R | BMSIT&amp;M</a:t>
             </a:r>
           </a:p>
         </p:txBody>
@@ -3674,7 +3674,7 @@
               </a:defRPr>
             </a:pPr>
             <a:r>
-              <a:t>• Team Members: Kanchana A (GitHub: @kanchanadoddaballapur-a11y) &amp; Sinchana (USN: 1TE25CS281)</a:t>
+              <a:t>• Team Members: Kanchana A, Sinchana (USN: 1TE25CS281), Bhanushree M, Bhuvana H R</a:t>
             </a:r>
           </a:p>
           <a:p>

</xml_diff>